<commit_message>
updated track for the symposium
</commit_message>
<xml_diff>
--- a/lesson_24-symposium/lesson_24-symposium.pptx
+++ b/lesson_24-symposium/lesson_24-symposium.pptx
@@ -201,7 +201,7 @@
           <a:p>
             <a:fld id="{81C4B3FE-0320-8142-8396-5C3025C019EC}" type="datetimeFigureOut">
               <a:rPr lang="en-IT" smtClean="0"/>
-              <a:t>2/18/26</a:t>
+              <a:t>5/28/26</a:t>
             </a:fld>
             <a:endParaRPr lang="en-IT"/>
           </a:p>
@@ -3511,7 +3511,7 @@
           <a:p>
             <a:r>
               <a:rPr lang="en-US" dirty="0"/>
-              <a:t>2 laps of the DEI “main” building running (or walking as fast as possible)</a:t>
+              <a:t>2 laps of the DEI “highway” running (or walking as fast as possible)</a:t>
             </a:r>
           </a:p>
           <a:p>
@@ -3581,258 +3581,6 @@
           </a:prstGeom>
         </p:spPr>
       </p:pic>
-      <p:pic>
-        <p:nvPicPr>
-          <p:cNvPr id="27" name="Picture 26" descr="A aerial view of a building&#10;&#10;Description automatically generated">
-            <a:extLst>
-              <a:ext uri="{FF2B5EF4-FFF2-40B4-BE49-F238E27FC236}">
-                <a16:creationId xmlns:a16="http://schemas.microsoft.com/office/drawing/2014/main" id="{C2350770-E33B-6BCA-89D3-97A8D0D1D8C7}"/>
-              </a:ext>
-            </a:extLst>
-          </p:cNvPr>
-          <p:cNvPicPr>
-            <a:picLocks noChangeAspect="1"/>
-          </p:cNvPicPr>
-          <p:nvPr/>
-        </p:nvPicPr>
-        <p:blipFill>
-          <a:blip r:embed="rId5">
-            <a:extLst>
-              <a:ext uri="{28A0092B-C50C-407E-A947-70E740481C1C}">
-                <a14:useLocalDpi xmlns:a14="http://schemas.microsoft.com/office/drawing/2010/main" val="0"/>
-              </a:ext>
-            </a:extLst>
-          </a:blip>
-          <a:stretch>
-            <a:fillRect/>
-          </a:stretch>
-        </p:blipFill>
-        <p:spPr>
-          <a:xfrm>
-            <a:off x="3539440" y="3255394"/>
-            <a:ext cx="2514060" cy="3426241"/>
-          </a:xfrm>
-          <a:prstGeom prst="rect">
-            <a:avLst/>
-          </a:prstGeom>
-        </p:spPr>
-      </p:pic>
-      <p:sp>
-        <p:nvSpPr>
-          <p:cNvPr id="32" name="Down Arrow 31">
-            <a:extLst>
-              <a:ext uri="{FF2B5EF4-FFF2-40B4-BE49-F238E27FC236}">
-                <a16:creationId xmlns:a16="http://schemas.microsoft.com/office/drawing/2014/main" id="{ED079F7D-D51F-67E3-70C0-52D9FD51B84B}"/>
-              </a:ext>
-            </a:extLst>
-          </p:cNvPr>
-          <p:cNvSpPr/>
-          <p:nvPr/>
-        </p:nvSpPr>
-        <p:spPr>
-          <a:xfrm rot="631478">
-            <a:off x="5581441" y="3661054"/>
-            <a:ext cx="328863" cy="3015916"/>
-          </a:xfrm>
-          <a:prstGeom prst="downArrow">
-            <a:avLst/>
-          </a:prstGeom>
-          <a:solidFill>
-            <a:srgbClr val="FF0000"/>
-          </a:solidFill>
-          <a:ln>
-            <a:solidFill>
-              <a:srgbClr val="FF0000"/>
-            </a:solidFill>
-          </a:ln>
-        </p:spPr>
-        <p:style>
-          <a:lnRef idx="2">
-            <a:schemeClr val="accent1">
-              <a:shade val="15000"/>
-            </a:schemeClr>
-          </a:lnRef>
-          <a:fillRef idx="1">
-            <a:schemeClr val="accent1"/>
-          </a:fillRef>
-          <a:effectRef idx="0">
-            <a:schemeClr val="accent1"/>
-          </a:effectRef>
-          <a:fontRef idx="minor">
-            <a:schemeClr val="lt1"/>
-          </a:fontRef>
-        </p:style>
-        <p:txBody>
-          <a:bodyPr rtlCol="0" anchor="ctr"/>
-          <a:lstStyle/>
-          <a:p>
-            <a:pPr algn="ctr"/>
-            <a:endParaRPr lang="en-US"/>
-          </a:p>
-        </p:txBody>
-      </p:sp>
-      <p:sp>
-        <p:nvSpPr>
-          <p:cNvPr id="33" name="Down Arrow 32">
-            <a:extLst>
-              <a:ext uri="{FF2B5EF4-FFF2-40B4-BE49-F238E27FC236}">
-                <a16:creationId xmlns:a16="http://schemas.microsoft.com/office/drawing/2014/main" id="{CE2480AE-21C6-EFBD-B5E7-47B4F6356E0D}"/>
-              </a:ext>
-            </a:extLst>
-          </p:cNvPr>
-          <p:cNvSpPr/>
-          <p:nvPr/>
-        </p:nvSpPr>
-        <p:spPr>
-          <a:xfrm rot="11479313">
-            <a:off x="3636200" y="3316508"/>
-            <a:ext cx="328863" cy="3015916"/>
-          </a:xfrm>
-          <a:prstGeom prst="downArrow">
-            <a:avLst/>
-          </a:prstGeom>
-          <a:solidFill>
-            <a:srgbClr val="FF0000"/>
-          </a:solidFill>
-          <a:ln>
-            <a:solidFill>
-              <a:srgbClr val="FF0000"/>
-            </a:solidFill>
-          </a:ln>
-        </p:spPr>
-        <p:style>
-          <a:lnRef idx="2">
-            <a:schemeClr val="accent1">
-              <a:shade val="15000"/>
-            </a:schemeClr>
-          </a:lnRef>
-          <a:fillRef idx="1">
-            <a:schemeClr val="accent1"/>
-          </a:fillRef>
-          <a:effectRef idx="0">
-            <a:schemeClr val="accent1"/>
-          </a:effectRef>
-          <a:fontRef idx="minor">
-            <a:schemeClr val="lt1"/>
-          </a:fontRef>
-        </p:style>
-        <p:txBody>
-          <a:bodyPr rtlCol="0" anchor="ctr"/>
-          <a:lstStyle/>
-          <a:p>
-            <a:pPr algn="ctr"/>
-            <a:endParaRPr lang="en-US"/>
-          </a:p>
-        </p:txBody>
-      </p:sp>
-      <p:sp>
-        <p:nvSpPr>
-          <p:cNvPr id="36" name="Down Arrow 35">
-            <a:extLst>
-              <a:ext uri="{FF2B5EF4-FFF2-40B4-BE49-F238E27FC236}">
-                <a16:creationId xmlns:a16="http://schemas.microsoft.com/office/drawing/2014/main" id="{E58F5445-2FF3-F162-6567-8F8B9A455CDA}"/>
-              </a:ext>
-            </a:extLst>
-          </p:cNvPr>
-          <p:cNvSpPr/>
-          <p:nvPr/>
-        </p:nvSpPr>
-        <p:spPr>
-          <a:xfrm rot="5956526">
-            <a:off x="4290508" y="5654672"/>
-            <a:ext cx="328863" cy="1801546"/>
-          </a:xfrm>
-          <a:prstGeom prst="downArrow">
-            <a:avLst/>
-          </a:prstGeom>
-          <a:solidFill>
-            <a:srgbClr val="FF0000"/>
-          </a:solidFill>
-          <a:ln>
-            <a:solidFill>
-              <a:srgbClr val="FF0000"/>
-            </a:solidFill>
-          </a:ln>
-        </p:spPr>
-        <p:style>
-          <a:lnRef idx="2">
-            <a:schemeClr val="accent1">
-              <a:shade val="15000"/>
-            </a:schemeClr>
-          </a:lnRef>
-          <a:fillRef idx="1">
-            <a:schemeClr val="accent1"/>
-          </a:fillRef>
-          <a:effectRef idx="0">
-            <a:schemeClr val="accent1"/>
-          </a:effectRef>
-          <a:fontRef idx="minor">
-            <a:schemeClr val="lt1"/>
-          </a:fontRef>
-        </p:style>
-        <p:txBody>
-          <a:bodyPr rtlCol="0" anchor="ctr"/>
-          <a:lstStyle/>
-          <a:p>
-            <a:pPr algn="ctr"/>
-            <a:endParaRPr lang="en-US"/>
-          </a:p>
-        </p:txBody>
-      </p:sp>
-      <p:sp>
-        <p:nvSpPr>
-          <p:cNvPr id="40" name="Down Arrow 39">
-            <a:extLst>
-              <a:ext uri="{FF2B5EF4-FFF2-40B4-BE49-F238E27FC236}">
-                <a16:creationId xmlns:a16="http://schemas.microsoft.com/office/drawing/2014/main" id="{D5552FFF-41F6-96C4-FA4C-FB1B672A5E05}"/>
-              </a:ext>
-            </a:extLst>
-          </p:cNvPr>
-          <p:cNvSpPr/>
-          <p:nvPr/>
-        </p:nvSpPr>
-        <p:spPr>
-          <a:xfrm rot="16768234">
-            <a:off x="4901690" y="2475197"/>
-            <a:ext cx="328863" cy="1801546"/>
-          </a:xfrm>
-          <a:prstGeom prst="downArrow">
-            <a:avLst/>
-          </a:prstGeom>
-          <a:solidFill>
-            <a:srgbClr val="FF0000"/>
-          </a:solidFill>
-          <a:ln>
-            <a:solidFill>
-              <a:srgbClr val="FF0000"/>
-            </a:solidFill>
-          </a:ln>
-        </p:spPr>
-        <p:style>
-          <a:lnRef idx="2">
-            <a:schemeClr val="accent1">
-              <a:shade val="15000"/>
-            </a:schemeClr>
-          </a:lnRef>
-          <a:fillRef idx="1">
-            <a:schemeClr val="accent1"/>
-          </a:fillRef>
-          <a:effectRef idx="0">
-            <a:schemeClr val="accent1"/>
-          </a:effectRef>
-          <a:fontRef idx="minor">
-            <a:schemeClr val="lt1"/>
-          </a:fontRef>
-        </p:style>
-        <p:txBody>
-          <a:bodyPr rtlCol="0" anchor="ctr"/>
-          <a:lstStyle/>
-          <a:p>
-            <a:pPr algn="ctr"/>
-            <a:endParaRPr lang="en-US"/>
-          </a:p>
-        </p:txBody>
-      </p:sp>
       <p:sp>
         <p:nvSpPr>
           <p:cNvPr id="41" name="Oval 40">
@@ -3847,7 +3595,7 @@
         </p:nvSpPr>
         <p:spPr>
           <a:xfrm>
-            <a:off x="3343355" y="6245796"/>
+            <a:off x="8857556" y="6394964"/>
             <a:ext cx="320842" cy="301110"/>
           </a:xfrm>
           <a:prstGeom prst="ellipse">
@@ -3902,7 +3650,7 @@
         </p:nvSpPr>
         <p:spPr>
           <a:xfrm rot="9679481">
-            <a:off x="2642716" y="5338477"/>
+            <a:off x="318775" y="6656228"/>
             <a:ext cx="905854" cy="1052705"/>
           </a:xfrm>
           <a:prstGeom prst="arc">
@@ -3946,7 +3694,7 @@
         </p:nvSpPr>
         <p:spPr>
           <a:xfrm>
-            <a:off x="1747758" y="5612264"/>
+            <a:off x="771702" y="7456918"/>
             <a:ext cx="6097424" cy="369332"/>
           </a:xfrm>
           <a:prstGeom prst="rect">
@@ -3966,6 +3714,156 @@
               </a:rPr>
               <a:t>Start/Stop</a:t>
             </a:r>
+          </a:p>
+        </p:txBody>
+      </p:sp>
+      <p:pic>
+        <p:nvPicPr>
+          <p:cNvPr id="5" name="Picture 4">
+            <a:extLst>
+              <a:ext uri="{FF2B5EF4-FFF2-40B4-BE49-F238E27FC236}">
+                <a16:creationId xmlns:a16="http://schemas.microsoft.com/office/drawing/2014/main" id="{2A48C998-1F19-3CCA-FC24-6F887BC564CE}"/>
+              </a:ext>
+            </a:extLst>
+          </p:cNvPr>
+          <p:cNvPicPr>
+            <a:picLocks noChangeAspect="1"/>
+          </p:cNvPicPr>
+          <p:nvPr/>
+        </p:nvPicPr>
+        <p:blipFill>
+          <a:blip r:embed="rId5">
+            <a:extLst>
+              <a:ext uri="{28A0092B-C50C-407E-A947-70E740481C1C}">
+                <a14:useLocalDpi xmlns:a14="http://schemas.microsoft.com/office/drawing/2010/main" val="0"/>
+              </a:ext>
+            </a:extLst>
+          </a:blip>
+          <a:stretch>
+            <a:fillRect/>
+          </a:stretch>
+        </p:blipFill>
+        <p:spPr>
+          <a:xfrm>
+            <a:off x="3254140" y="3323296"/>
+            <a:ext cx="2738372" cy="3375502"/>
+          </a:xfrm>
+          <a:prstGeom prst="rect">
+            <a:avLst/>
+          </a:prstGeom>
+        </p:spPr>
+      </p:pic>
+      <p:sp>
+        <p:nvSpPr>
+          <p:cNvPr id="6" name="Down Arrow 5">
+            <a:extLst>
+              <a:ext uri="{FF2B5EF4-FFF2-40B4-BE49-F238E27FC236}">
+                <a16:creationId xmlns:a16="http://schemas.microsoft.com/office/drawing/2014/main" id="{DAE6A564-12B0-B80A-7880-F78A573995C8}"/>
+              </a:ext>
+            </a:extLst>
+          </p:cNvPr>
+          <p:cNvSpPr/>
+          <p:nvPr/>
+        </p:nvSpPr>
+        <p:spPr>
+          <a:xfrm rot="631478">
+            <a:off x="4162927" y="3412553"/>
+            <a:ext cx="166279" cy="1880976"/>
+          </a:xfrm>
+          <a:prstGeom prst="downArrow">
+            <a:avLst>
+              <a:gd name="adj1" fmla="val 15663"/>
+              <a:gd name="adj2" fmla="val 47286"/>
+            </a:avLst>
+          </a:prstGeom>
+          <a:solidFill>
+            <a:srgbClr val="FF0000"/>
+          </a:solidFill>
+          <a:ln>
+            <a:solidFill>
+              <a:srgbClr val="FF0000"/>
+            </a:solidFill>
+          </a:ln>
+        </p:spPr>
+        <p:style>
+          <a:lnRef idx="2">
+            <a:schemeClr val="accent1">
+              <a:shade val="15000"/>
+            </a:schemeClr>
+          </a:lnRef>
+          <a:fillRef idx="1">
+            <a:schemeClr val="accent1"/>
+          </a:fillRef>
+          <a:effectRef idx="0">
+            <a:schemeClr val="accent1"/>
+          </a:effectRef>
+          <a:fontRef idx="minor">
+            <a:schemeClr val="lt1"/>
+          </a:fontRef>
+        </p:style>
+        <p:txBody>
+          <a:bodyPr rtlCol="0" anchor="ctr"/>
+          <a:lstStyle/>
+          <a:p>
+            <a:pPr algn="ctr"/>
+            <a:endParaRPr lang="en-US"/>
+          </a:p>
+        </p:txBody>
+      </p:sp>
+      <p:sp>
+        <p:nvSpPr>
+          <p:cNvPr id="7" name="Down Arrow 6">
+            <a:extLst>
+              <a:ext uri="{FF2B5EF4-FFF2-40B4-BE49-F238E27FC236}">
+                <a16:creationId xmlns:a16="http://schemas.microsoft.com/office/drawing/2014/main" id="{39705126-AA88-D725-A860-2B01A0877F2F}"/>
+              </a:ext>
+            </a:extLst>
+          </p:cNvPr>
+          <p:cNvSpPr/>
+          <p:nvPr/>
+        </p:nvSpPr>
+        <p:spPr>
+          <a:xfrm rot="11436811">
+            <a:off x="4307697" y="3415047"/>
+            <a:ext cx="147026" cy="1844461"/>
+          </a:xfrm>
+          <a:prstGeom prst="downArrow">
+            <a:avLst>
+              <a:gd name="adj1" fmla="val 15663"/>
+              <a:gd name="adj2" fmla="val 47286"/>
+            </a:avLst>
+          </a:prstGeom>
+          <a:solidFill>
+            <a:srgbClr val="FF0000"/>
+          </a:solidFill>
+          <a:ln>
+            <a:solidFill>
+              <a:srgbClr val="FF0000"/>
+            </a:solidFill>
+          </a:ln>
+        </p:spPr>
+        <p:style>
+          <a:lnRef idx="2">
+            <a:schemeClr val="accent1">
+              <a:shade val="15000"/>
+            </a:schemeClr>
+          </a:lnRef>
+          <a:fillRef idx="1">
+            <a:schemeClr val="accent1"/>
+          </a:fillRef>
+          <a:effectRef idx="0">
+            <a:schemeClr val="accent1"/>
+          </a:effectRef>
+          <a:fontRef idx="minor">
+            <a:schemeClr val="lt1"/>
+          </a:fontRef>
+        </p:style>
+        <p:txBody>
+          <a:bodyPr rtlCol="0" anchor="ctr"/>
+          <a:lstStyle/>
+          <a:p>
+            <a:pPr algn="ctr"/>
+            <a:endParaRPr lang="en-US"/>
           </a:p>
         </p:txBody>
       </p:sp>

</xml_diff>